<commit_message>
Publish verified Firebase release and narrated submission package
</commit_message>
<xml_diff>
--- a/docs/deliverables/groundproof-pitch.pptx
+++ b/docs/deliverables/groundproof-pitch.pptx
@@ -2,22 +2,22 @@
 <file path=ppt/presentation.xml><?xml version="1.0" encoding="utf-8"?>
 <p:presentation xmlns:p="http://schemas.openxmlformats.org/presentationml/2006/main">
   <p:sldMasterIdLst>
-    <p:sldMasterId xmlns:r="http://schemas.openxmlformats.org/officeDocument/2006/relationships" id="2147483648" r:id="Rd5049276c1fd42ee"/>
+    <p:sldMasterId xmlns:r="http://schemas.openxmlformats.org/officeDocument/2006/relationships" id="2147483648" r:id="R55513f2d225c4e23"/>
   </p:sldMasterIdLst>
   <p:notesMasterIdLst>
-    <p:notesMasterId xmlns:r="http://schemas.openxmlformats.org/officeDocument/2006/relationships" r:id="R16c3fcb7111d44f0"/>
+    <p:notesMasterId xmlns:r="http://schemas.openxmlformats.org/officeDocument/2006/relationships" r:id="R02f6a9ba21134ec2"/>
   </p:notesMasterIdLst>
   <p:sldIdLst>
-    <p:sldId xmlns:r="http://schemas.openxmlformats.org/officeDocument/2006/relationships" id="256" r:id="R361f071530c240f7"/>
-    <p:sldId xmlns:r="http://schemas.openxmlformats.org/officeDocument/2006/relationships" id="257" r:id="R7f57a0e121164ab8"/>
-    <p:sldId xmlns:r="http://schemas.openxmlformats.org/officeDocument/2006/relationships" id="258" r:id="R31bbe3827e0045c6"/>
-    <p:sldId xmlns:r="http://schemas.openxmlformats.org/officeDocument/2006/relationships" id="259" r:id="Rac980b7392dd477a"/>
-    <p:sldId xmlns:r="http://schemas.openxmlformats.org/officeDocument/2006/relationships" id="260" r:id="R03bb6376aef44392"/>
-    <p:sldId xmlns:r="http://schemas.openxmlformats.org/officeDocument/2006/relationships" id="261" r:id="R24e793ea760244cd"/>
-    <p:sldId xmlns:r="http://schemas.openxmlformats.org/officeDocument/2006/relationships" id="262" r:id="R0c33cfcb593b4e22"/>
-    <p:sldId xmlns:r="http://schemas.openxmlformats.org/officeDocument/2006/relationships" id="263" r:id="R62783935b96141fc"/>
-    <p:sldId xmlns:r="http://schemas.openxmlformats.org/officeDocument/2006/relationships" id="264" r:id="Rb16a93a7fd694c0b"/>
-    <p:sldId xmlns:r="http://schemas.openxmlformats.org/officeDocument/2006/relationships" id="265" r:id="Re621c34446e44677"/>
+    <p:sldId xmlns:r="http://schemas.openxmlformats.org/officeDocument/2006/relationships" id="256" r:id="Rd761c2a6121a4826"/>
+    <p:sldId xmlns:r="http://schemas.openxmlformats.org/officeDocument/2006/relationships" id="257" r:id="Rb80cdb222b7049b8"/>
+    <p:sldId xmlns:r="http://schemas.openxmlformats.org/officeDocument/2006/relationships" id="258" r:id="R35b9ce215dc64a4f"/>
+    <p:sldId xmlns:r="http://schemas.openxmlformats.org/officeDocument/2006/relationships" id="259" r:id="R60a94562be334663"/>
+    <p:sldId xmlns:r="http://schemas.openxmlformats.org/officeDocument/2006/relationships" id="260" r:id="Rb5bbf89937084641"/>
+    <p:sldId xmlns:r="http://schemas.openxmlformats.org/officeDocument/2006/relationships" id="261" r:id="R5a022290d4a34cc7"/>
+    <p:sldId xmlns:r="http://schemas.openxmlformats.org/officeDocument/2006/relationships" id="262" r:id="Rcfe60f0bfd7841eb"/>
+    <p:sldId xmlns:r="http://schemas.openxmlformats.org/officeDocument/2006/relationships" id="263" r:id="Rd6f6713fb5e44409"/>
+    <p:sldId xmlns:r="http://schemas.openxmlformats.org/officeDocument/2006/relationships" id="264" r:id="R2681352938c2487a"/>
+    <p:sldId xmlns:r="http://schemas.openxmlformats.org/officeDocument/2006/relationships" id="265" r:id="R7e12edffc5a64e7e"/>
   </p:sldIdLst>
   <p:sldSz cx="12192000" cy="6858000"/>
   <p:notesSz cx="6858000" cy="9144000"/>
@@ -661,7 +661,7 @@
           <a:lstStyle xmlns:a="http://schemas.openxmlformats.org/drawingml/2006/main"/>
           <a:p xmlns:a="http://schemas.openxmlformats.org/drawingml/2006/main">
             <a:r>
-              <a:t>Product screenshot shows the actual application with fictional demo data. It may contain illustrative booked values, which are not earned revenue or savings. Source capture, source review, and mission approval are distinct operations.</a:t>
+              <a:t>Product screenshot shows the actual application with fictional demo data. It may contain illustrative planned values, which are not earned revenue or savings. Source capture, source review, and mission approval are distinct operations.</a:t>
             </a:r>
           </a:p>
         </p:txBody>
@@ -731,7 +731,7 @@
           <a:lstStyle xmlns:a="http://schemas.openxmlformats.org/drawingml/2006/main"/>
           <a:p xmlns:a="http://schemas.openxmlformats.org/drawingml/2006/main">
             <a:r>
-              <a:t>The demo dataset has six jobs, three sites and five sources. The Harbor Works fixture affects the first three jobs with a combined illustrative booked value of $4,800. This is a controlled simulation. It demonstrates dependency propagation and version-bound approval, not financial loss avoided.</a:t>
+              <a:t>The demo dataset has six jobs, three sites and five sources. The Harbor Works fixture affects the first three jobs with a combined illustrative planned value of $4,800. This is a controlled simulation. It demonstrates dependency propagation and version-bound approval, not financial loss avoided.</a:t>
             </a:r>
           </a:p>
         </p:txBody>
@@ -801,7 +801,7 @@
           <a:lstStyle xmlns:a="http://schemas.openxmlformats.org/drawingml/2006/main"/>
           <a:p xmlns:a="http://schemas.openxmlformats.org/drawingml/2006/main">
             <a:r>
-              <a:t>The server checks source hashes and review decisions, tenant ownership, timestamps, and approval inputs. This is operational evidence administration, not flight authorization. The rule lab executes authored test scenarios. Exact test counts belong in the release validation report and live demonstration.</a:t>
+              <a:t>The server checks source hashes and review decisions, tenant ownership, timestamps, exact evidence coverage and the current mission revision. This is operational evidence administration, not flight authorization. The rule lab executes authored test scenarios. Exact test counts belong in the release validation report and live demonstration.</a:t>
             </a:r>
           </a:p>
         </p:txBody>
@@ -871,7 +871,7 @@
           <a:lstStyle xmlns:a="http://schemas.openxmlformats.org/drawingml/2006/main"/>
           <a:p xmlns:a="http://schemas.openxmlformats.org/drawingml/2006/main">
             <a:r>
-              <a:t>Authenticated Anakin retrieval verified September 23, 2026 at 10:06:40 UTC: Boston public filming guidance, 5,930 characters in 2,458 ms. Evidence file docs/deliverables/anakin-integration-proof.json. This single call is not an availability or completeness benchmark. No customer, pilot partner, revenue, flight performance, certification, or prevented incident is claimed. Evidence packet hashes show content consistency. They do not establish source truth, a genuine permit, or legal compliance. GroundProof leaves flight decisions with the operator and remote pilot.</a:t>
+              <a:t>Authenticated Anakin retrieval verified September 23, 2026 at 10:06:40 UTC: Boston public filming guidance, 5,930 characters in 2,458 ms. Evidence file docs/deliverables/anakin-integration-proof.json. This single call is not an availability or completeness benchmark. The hosted frontend uses Firebase Hosting with a Cloud Run API gateway to a Cloudflare Worker and durable SQLite database. Accounts support single-use saved recovery keys, password changes and session revocation. Retained source captures have paginated history and content-integrity checks. No customer, pilot partner, revenue, flight performance, certification, or prevented incident is claimed. Evidence packet hashes show content consistency. They do not establish source truth, a genuine permit, or legal compliance. GroundProof leaves flight decisions with the operator and remote pilot.</a:t>
             </a:r>
           </a:p>
         </p:txBody>
@@ -1011,7 +1011,7 @@
           <a:lstStyle xmlns:a="http://schemas.openxmlformats.org/drawingml/2006/main"/>
           <a:p xmlns:a="http://schemas.openxmlformats.org/drawingml/2006/main">
             <a:r>
-              <a:t>All commercial numbers are hypotheses. Exact values $266.67 and $133.33 rounded to nearest dollar. Time capacity is not guaranteed payroll savings. Planning direct-cost case is $19 Anakin + $25 infrastructure + $20 support = $64 monthly cost, before other expenses. Anakin pricing inspected September 23, 2026 at https://anakin.io/pricing . 25 sites x 2 sources x 2 daily checks x 30 days = 3,000 basic captures, within the stated 5,000 Pro credits. Scheduled source monitoring and protective supplier budgets are implemented. Commercial billing and multi-user membership remain future work. The initial pilot uses one named coordinator account.</a:t>
+              <a:t>All commercial numbers are hypotheses. Exact values $266.67 and $133.33 rounded to nearest dollar. Time capacity is not guaranteed payroll savings. Planning direct-cost case is $19 Anakin + $25 infrastructure + $20 support = $64 monthly cost, before other expenses. Anakin pricing inspected September 23, 2026 at https://anakin.io/pricing . 25 sites x 2 sources x 2 daily checks x 30 days = 3,000 basic captures, within the stated 5,000 Pro credits. Scheduled source monitoring and protective supplier budgets are implemented. Commercial billing and multi-user membership remain future work. The current product and initial pilot use one named coordinator account. The 25-site/five-user plan is future scope, not available team membership. A higher-volume paid deployment would require adjusting supplier budgets and verifying actual cost.</a:t>
             </a:r>
           </a:p>
         </p:txBody>
@@ -1081,7 +1081,7 @@
           <a:lstStyle xmlns:a="http://schemas.openxmlformats.org/drawingml/2006/main"/>
           <a:p xmlns:a="http://schemas.openxmlformats.org/drawingml/2006/main">
             <a:r>
-              <a:t>Pilot proposal only. Target 5-10 recurring sites and at least 30 job reviews if available. These are feasibility targets, not a statistically powered study. Maintain operator dispatch procedures throughout. Stop for an approval-control bypass or access-control defect. Full definitions and go/no-go criteria: docs/PILOT.md.</a:t>
+              <a:t>Pilot proposal only. Target 5-10 recurring sites and at least 30 job reviews if available. These are feasibility targets, not a statistically powered study. Maintain operator dispatch procedures throughout. Stop for an approval-control bypass or access-control defect. Measure total effort, including entering and maintaining private-record excerpts. Full definitions and go/no-go criteria: docs/PILOT.md.</a:t>
             </a:r>
           </a:p>
         </p:txBody>
@@ -1149,7 +1149,7 @@
   </p:cSld>
   <p:clrMap bg1="lt1" tx1="dk1" bg2="lt2" tx2="dk2" accent1="accent1" accent2="accent2" accent3="accent3" accent4="accent4" accent5="accent5" accent6="accent6" hlink="hlink" folHlink="folHlink"/>
   <p:sldLayoutIdLst>
-    <p:sldLayoutId xmlns:r="http://schemas.openxmlformats.org/officeDocument/2006/relationships" id="2147483649" r:id="R70fdd12264da4691"/>
+    <p:sldLayoutId xmlns:r="http://schemas.openxmlformats.org/officeDocument/2006/relationships" id="2147483649" r:id="Rf0d3c92eda7c4014"/>
   </p:sldLayoutIdLst>
   <p:txStyles>
     <p:titleStyle>
@@ -1700,7 +1700,7 @@
           <p:cNvPr id="7" name="">
             <a:extLst xmlns:a="http://schemas.openxmlformats.org/drawingml/2006/main">
               <a:ext uri="{FF2B5EF4-FFF2-40B4-BE49-F238E27FC236}">
-                <a16:creationId xmlns:a16="http://schemas.microsoft.com/office/drawing/2014/main" id="{DCA3E453-EA1B-490C-AB82-39D6675A87D3}"/>
+                <a16:creationId xmlns:a16="http://schemas.microsoft.com/office/drawing/2014/main" id="{CE2A7DC7-BDBB-41D9-9C96-3FC796739980}"/>
               </a:ext>
             </a:extLst>
           </p:cNvPr>
@@ -1757,7 +1757,7 @@
           <p:cNvPr id="2" name="">
             <a:extLst xmlns:a="http://schemas.openxmlformats.org/drawingml/2006/main">
               <a:ext uri="{FF2B5EF4-FFF2-40B4-BE49-F238E27FC236}">
-                <a16:creationId xmlns:a16="http://schemas.microsoft.com/office/drawing/2014/main" id="{96121CD1-FB6A-4D75-AA75-11C9DD6316D3}"/>
+                <a16:creationId xmlns:a16="http://schemas.microsoft.com/office/drawing/2014/main" id="{0B3CCCDD-B438-44E5-B2D7-59DCA7B1A3B6}"/>
               </a:ext>
             </a:extLst>
           </p:cNvPr>
@@ -1814,7 +1814,7 @@
           <p:cNvPr id="3" name="">
             <a:extLst xmlns:a="http://schemas.openxmlformats.org/drawingml/2006/main">
               <a:ext uri="{FF2B5EF4-FFF2-40B4-BE49-F238E27FC236}">
-                <a16:creationId xmlns:a16="http://schemas.microsoft.com/office/drawing/2014/main" id="{58C52858-71E5-41AA-A092-1BEA4D9300D4}"/>
+                <a16:creationId xmlns:a16="http://schemas.microsoft.com/office/drawing/2014/main" id="{33A4BEAD-73CE-4F21-842F-EFA4514A364D}"/>
               </a:ext>
             </a:extLst>
           </p:cNvPr>
@@ -1894,7 +1894,7 @@
           <p:cNvPr id="4" name="">
             <a:extLst xmlns:a="http://schemas.openxmlformats.org/drawingml/2006/main">
               <a:ext uri="{FF2B5EF4-FFF2-40B4-BE49-F238E27FC236}">
-                <a16:creationId xmlns:a16="http://schemas.microsoft.com/office/drawing/2014/main" id="{37C37411-C13C-4753-A7C5-2714678AF628}"/>
+                <a16:creationId xmlns:a16="http://schemas.microsoft.com/office/drawing/2014/main" id="{ABF9D91B-6AE4-420B-AF94-D3890CC59B1D}"/>
               </a:ext>
             </a:extLst>
           </p:cNvPr>
@@ -1941,7 +1941,7 @@
                 <a:ea typeface="Liberation Sans"/>
                 <a:cs typeface="Liberation Sans"/>
               </a:rPr>
-              <a:t>Operational evidence for drone inspection teams</a:t>
+              <a:t>Operational evidence for drone inspection coordinators</a:t>
             </a:r>
           </a:p>
         </p:txBody>
@@ -1951,7 +1951,7 @@
           <p:cNvPr id="5" name="">
             <a:extLst xmlns:a="http://schemas.openxmlformats.org/drawingml/2006/main">
               <a:ext uri="{FF2B5EF4-FFF2-40B4-BE49-F238E27FC236}">
-                <a16:creationId xmlns:a16="http://schemas.microsoft.com/office/drawing/2014/main" id="{EE5BE4F9-4F3B-4991-B8E8-7EB5AEB8F8B3}"/>
+                <a16:creationId xmlns:a16="http://schemas.microsoft.com/office/drawing/2014/main" id="{49FDE779-2C80-4F8E-8A94-82DD63E56225}"/>
               </a:ext>
             </a:extLst>
           </p:cNvPr>
@@ -2008,7 +2008,7 @@
           <p:cNvPr id="6" name="">
             <a:extLst xmlns:a="http://schemas.openxmlformats.org/drawingml/2006/main">
               <a:ext uri="{FF2B5EF4-FFF2-40B4-BE49-F238E27FC236}">
-                <a16:creationId xmlns:a16="http://schemas.microsoft.com/office/drawing/2014/main" id="{FD47859E-964F-4E5B-A52D-FD15058CCA28}"/>
+                <a16:creationId xmlns:a16="http://schemas.microsoft.com/office/drawing/2014/main" id="{C37B5FD9-A3D4-412E-85DD-D27F0082C82B}"/>
               </a:ext>
             </a:extLst>
           </p:cNvPr>
@@ -2063,7 +2063,7 @@
     </p:spTree>
     <p:extLst>
       <p:ext uri="{BB962C8B-B14F-4D97-AF65-F5344CB8AC3E}">
-        <p14:creationId xmlns:p14="http://schemas.microsoft.com/office/powerpoint/2010/main" val="449311278"/>
+        <p14:creationId xmlns:p14="http://schemas.microsoft.com/office/powerpoint/2010/main" val="1977036076"/>
       </p:ext>
     </p:extLst>
   </p:cSld>
@@ -2094,7 +2094,7 @@
           <p:cNvPr id="7" name="">
             <a:extLst xmlns:a="http://schemas.openxmlformats.org/drawingml/2006/main">
               <a:ext uri="{FF2B5EF4-FFF2-40B4-BE49-F238E27FC236}">
-                <a16:creationId xmlns:a16="http://schemas.microsoft.com/office/drawing/2014/main" id="{0A9C7401-AB26-4215-93CF-202508CC5272}"/>
+                <a16:creationId xmlns:a16="http://schemas.microsoft.com/office/drawing/2014/main" id="{20BCA8B4-F818-4A5C-A721-E56674C928E7}"/>
               </a:ext>
             </a:extLst>
           </p:cNvPr>
@@ -2151,7 +2151,7 @@
           <p:cNvPr id="2" name="">
             <a:extLst xmlns:a="http://schemas.openxmlformats.org/drawingml/2006/main">
               <a:ext uri="{FF2B5EF4-FFF2-40B4-BE49-F238E27FC236}">
-                <a16:creationId xmlns:a16="http://schemas.microsoft.com/office/drawing/2014/main" id="{75FF5BC1-4F6F-46A3-A2B5-2A4E48B346D8}"/>
+                <a16:creationId xmlns:a16="http://schemas.microsoft.com/office/drawing/2014/main" id="{F7931109-7A5F-4797-8C61-82855C2A4336}"/>
               </a:ext>
             </a:extLst>
           </p:cNvPr>
@@ -2208,7 +2208,7 @@
           <p:cNvPr id="3" name="">
             <a:extLst xmlns:a="http://schemas.openxmlformats.org/drawingml/2006/main">
               <a:ext uri="{FF2B5EF4-FFF2-40B4-BE49-F238E27FC236}">
-                <a16:creationId xmlns:a16="http://schemas.microsoft.com/office/drawing/2014/main" id="{EF3456D5-B8A1-478A-A09C-7E2158DEC894}"/>
+                <a16:creationId xmlns:a16="http://schemas.microsoft.com/office/drawing/2014/main" id="{3ACCEB67-34CF-4B85-8F64-9FECD466134A}"/>
               </a:ext>
             </a:extLst>
           </p:cNvPr>
@@ -2265,7 +2265,7 @@
           <p:cNvPr id="4" name="">
             <a:extLst xmlns:a="http://schemas.openxmlformats.org/drawingml/2006/main">
               <a:ext uri="{FF2B5EF4-FFF2-40B4-BE49-F238E27FC236}">
-                <a16:creationId xmlns:a16="http://schemas.microsoft.com/office/drawing/2014/main" id="{71A2FF27-4AA6-4D6E-A4AA-C916450F0158}"/>
+                <a16:creationId xmlns:a16="http://schemas.microsoft.com/office/drawing/2014/main" id="{52D46C7C-B973-43A8-B817-62720D156F38}"/>
               </a:ext>
             </a:extLst>
           </p:cNvPr>
@@ -2368,7 +2368,7 @@
           <p:cNvPr id="5" name="">
             <a:extLst xmlns:a="http://schemas.openxmlformats.org/drawingml/2006/main">
               <a:ext uri="{FF2B5EF4-FFF2-40B4-BE49-F238E27FC236}">
-                <a16:creationId xmlns:a16="http://schemas.microsoft.com/office/drawing/2014/main" id="{DBEA8386-B456-4B1A-91EC-774269472D3A}"/>
+                <a16:creationId xmlns:a16="http://schemas.microsoft.com/office/drawing/2014/main" id="{090144B7-0B94-4844-85E1-0CFAE274F872}"/>
               </a:ext>
             </a:extLst>
           </p:cNvPr>
@@ -2448,7 +2448,7 @@
           <p:cNvPr id="6" name="">
             <a:extLst xmlns:a="http://schemas.openxmlformats.org/drawingml/2006/main">
               <a:ext uri="{FF2B5EF4-FFF2-40B4-BE49-F238E27FC236}">
-                <a16:creationId xmlns:a16="http://schemas.microsoft.com/office/drawing/2014/main" id="{76E8F545-09B0-49DB-9D9E-D24CF355F6B7}"/>
+                <a16:creationId xmlns:a16="http://schemas.microsoft.com/office/drawing/2014/main" id="{257FBBDE-6ADF-4DAA-AFA4-9F40E1B1C0C8}"/>
               </a:ext>
             </a:extLst>
           </p:cNvPr>
@@ -2494,9 +2494,9 @@
                 <a:latin typeface="Liberation Sans"/>
                 <a:ea typeface="Liberation Sans"/>
                 <a:cs typeface="Liberation Sans"/>
-                <a:hlinkClick xmlns:r="http://schemas.openxmlformats.org/officeDocument/2006/relationships" r:id="R55292c69d8d74fac"/>
-              </a:rPr>
-              <a:t>groundproof.groundproof.workers.dev</a:t>
+                <a:hlinkClick xmlns:r="http://schemas.openxmlformats.org/officeDocument/2006/relationships" r:id="R1b89c020073f42be"/>
+              </a:rPr>
+              <a:t>groundproof-flight.web.app</a:t>
             </a:r>
           </a:p>
         </p:txBody>
@@ -2504,7 +2504,7 @@
     </p:spTree>
     <p:extLst>
       <p:ext uri="{BB962C8B-B14F-4D97-AF65-F5344CB8AC3E}">
-        <p14:creationId xmlns:p14="http://schemas.microsoft.com/office/powerpoint/2010/main" val="863800174"/>
+        <p14:creationId xmlns:p14="http://schemas.microsoft.com/office/powerpoint/2010/main" val="663795262"/>
       </p:ext>
     </p:extLst>
   </p:cSld>
@@ -2535,7 +2535,7 @@
           <p:cNvPr id="11" name="">
             <a:extLst xmlns:a="http://schemas.openxmlformats.org/drawingml/2006/main">
               <a:ext uri="{FF2B5EF4-FFF2-40B4-BE49-F238E27FC236}">
-                <a16:creationId xmlns:a16="http://schemas.microsoft.com/office/drawing/2014/main" id="{40839DB9-2568-4430-9AE3-832D8AB7BB1D}"/>
+                <a16:creationId xmlns:a16="http://schemas.microsoft.com/office/drawing/2014/main" id="{DDD48451-FF0B-4016-B92D-D80DEC940063}"/>
               </a:ext>
             </a:extLst>
           </p:cNvPr>
@@ -2592,7 +2592,7 @@
           <p:cNvPr id="2" name="">
             <a:extLst xmlns:a="http://schemas.openxmlformats.org/drawingml/2006/main">
               <a:ext uri="{FF2B5EF4-FFF2-40B4-BE49-F238E27FC236}">
-                <a16:creationId xmlns:a16="http://schemas.microsoft.com/office/drawing/2014/main" id="{735A6A3B-8D72-47E8-8FFE-2174953A0B6D}"/>
+                <a16:creationId xmlns:a16="http://schemas.microsoft.com/office/drawing/2014/main" id="{20810F2C-7211-470B-BA5A-343700B8FDC0}"/>
               </a:ext>
             </a:extLst>
           </p:cNvPr>
@@ -2649,7 +2649,7 @@
           <p:cNvPr id="3" name="">
             <a:extLst xmlns:a="http://schemas.openxmlformats.org/drawingml/2006/main">
               <a:ext uri="{FF2B5EF4-FFF2-40B4-BE49-F238E27FC236}">
-                <a16:creationId xmlns:a16="http://schemas.microsoft.com/office/drawing/2014/main" id="{50B1787F-9775-451B-B9D8-5A0A1EC7FC2A}"/>
+                <a16:creationId xmlns:a16="http://schemas.microsoft.com/office/drawing/2014/main" id="{48203CB4-CD36-457E-AD81-B2F67D74FA76}"/>
               </a:ext>
             </a:extLst>
           </p:cNvPr>
@@ -2706,7 +2706,7 @@
           <p:cNvPr id="4" name="">
             <a:extLst xmlns:a="http://schemas.openxmlformats.org/drawingml/2006/main">
               <a:ext uri="{FF2B5EF4-FFF2-40B4-BE49-F238E27FC236}">
-                <a16:creationId xmlns:a16="http://schemas.microsoft.com/office/drawing/2014/main" id="{0FC167B5-CA8A-4530-A9BE-34A8C2CA286A}"/>
+                <a16:creationId xmlns:a16="http://schemas.microsoft.com/office/drawing/2014/main" id="{2EEFD10B-A57F-4048-AF45-E56FB72DF69E}"/>
               </a:ext>
             </a:extLst>
           </p:cNvPr>
@@ -2763,7 +2763,7 @@
           <p:cNvPr id="5" name="">
             <a:extLst xmlns:a="http://schemas.openxmlformats.org/drawingml/2006/main">
               <a:ext uri="{FF2B5EF4-FFF2-40B4-BE49-F238E27FC236}">
-                <a16:creationId xmlns:a16="http://schemas.microsoft.com/office/drawing/2014/main" id="{DBDF0403-B208-4394-9DF9-4206EEAEBAEE}"/>
+                <a16:creationId xmlns:a16="http://schemas.microsoft.com/office/drawing/2014/main" id="{A9F71F8E-194C-4297-8953-9439D7F23389}"/>
               </a:ext>
             </a:extLst>
           </p:cNvPr>
@@ -2820,7 +2820,7 @@
           <p:cNvPr id="6" name="">
             <a:extLst xmlns:a="http://schemas.openxmlformats.org/drawingml/2006/main">
               <a:ext uri="{FF2B5EF4-FFF2-40B4-BE49-F238E27FC236}">
-                <a16:creationId xmlns:a16="http://schemas.microsoft.com/office/drawing/2014/main" id="{852BD32A-B58B-48CC-9490-28C153769BFB}"/>
+                <a16:creationId xmlns:a16="http://schemas.microsoft.com/office/drawing/2014/main" id="{B7E9827F-8A5F-42EF-893A-2F3552F9E936}"/>
               </a:ext>
             </a:extLst>
           </p:cNvPr>
@@ -2877,7 +2877,7 @@
           <p:cNvPr id="7" name="">
             <a:extLst xmlns:a="http://schemas.openxmlformats.org/drawingml/2006/main">
               <a:ext uri="{FF2B5EF4-FFF2-40B4-BE49-F238E27FC236}">
-                <a16:creationId xmlns:a16="http://schemas.microsoft.com/office/drawing/2014/main" id="{273FB23D-387C-4077-A46C-6BBD0D142BE4}"/>
+                <a16:creationId xmlns:a16="http://schemas.microsoft.com/office/drawing/2014/main" id="{FE5795FD-C0A9-490A-99A3-2D55C907A448}"/>
               </a:ext>
             </a:extLst>
           </p:cNvPr>
@@ -2934,7 +2934,7 @@
           <p:cNvPr id="8" name="">
             <a:extLst xmlns:a="http://schemas.openxmlformats.org/drawingml/2006/main">
               <a:ext uri="{FF2B5EF4-FFF2-40B4-BE49-F238E27FC236}">
-                <a16:creationId xmlns:a16="http://schemas.microsoft.com/office/drawing/2014/main" id="{C6967789-CDB9-49E1-BA9E-9B3182185614}"/>
+                <a16:creationId xmlns:a16="http://schemas.microsoft.com/office/drawing/2014/main" id="{3476B36B-95D5-4150-A089-DF6BE77E2430}"/>
               </a:ext>
             </a:extLst>
           </p:cNvPr>
@@ -2991,7 +2991,7 @@
           <p:cNvPr id="9" name="">
             <a:extLst xmlns:a="http://schemas.openxmlformats.org/drawingml/2006/main">
               <a:ext uri="{FF2B5EF4-FFF2-40B4-BE49-F238E27FC236}">
-                <a16:creationId xmlns:a16="http://schemas.microsoft.com/office/drawing/2014/main" id="{C069EBF7-2D52-455C-A075-E7EC062BCE79}"/>
+                <a16:creationId xmlns:a16="http://schemas.microsoft.com/office/drawing/2014/main" id="{EC60DAF4-D2AB-45FE-958C-F8393848CECC}"/>
               </a:ext>
             </a:extLst>
           </p:cNvPr>
@@ -3048,7 +3048,7 @@
           <p:cNvPr id="10" name="">
             <a:extLst xmlns:a="http://schemas.openxmlformats.org/drawingml/2006/main">
               <a:ext uri="{FF2B5EF4-FFF2-40B4-BE49-F238E27FC236}">
-                <a16:creationId xmlns:a16="http://schemas.microsoft.com/office/drawing/2014/main" id="{420F4DA1-FD19-4F5E-A94C-4241613959D0}"/>
+                <a16:creationId xmlns:a16="http://schemas.microsoft.com/office/drawing/2014/main" id="{F6088C4A-9496-4C1E-8E8E-59009160BE53}"/>
               </a:ext>
             </a:extLst>
           </p:cNvPr>
@@ -3103,7 +3103,7 @@
     </p:spTree>
     <p:extLst>
       <p:ext uri="{BB962C8B-B14F-4D97-AF65-F5344CB8AC3E}">
-        <p14:creationId xmlns:p14="http://schemas.microsoft.com/office/powerpoint/2010/main" val="342102771"/>
+        <p14:creationId xmlns:p14="http://schemas.microsoft.com/office/powerpoint/2010/main" val="1521142341"/>
       </p:ext>
     </p:extLst>
   </p:cSld>
@@ -3134,7 +3134,7 @@
           <p:cNvPr id="7" name="">
             <a:extLst xmlns:a="http://schemas.openxmlformats.org/drawingml/2006/main">
               <a:ext uri="{FF2B5EF4-FFF2-40B4-BE49-F238E27FC236}">
-                <a16:creationId xmlns:a16="http://schemas.microsoft.com/office/drawing/2014/main" id="{9B8CDC2E-D506-4E68-980F-8B684D35B9E3}"/>
+                <a16:creationId xmlns:a16="http://schemas.microsoft.com/office/drawing/2014/main" id="{4BB4183F-BBD3-4289-9C4A-679139D7D43B}"/>
               </a:ext>
             </a:extLst>
           </p:cNvPr>
@@ -3191,7 +3191,7 @@
           <p:cNvPr id="2" name="">
             <a:extLst xmlns:a="http://schemas.openxmlformats.org/drawingml/2006/main">
               <a:ext uri="{FF2B5EF4-FFF2-40B4-BE49-F238E27FC236}">
-                <a16:creationId xmlns:a16="http://schemas.microsoft.com/office/drawing/2014/main" id="{CAB587CC-78DD-46DF-A5B3-9DF9C3B10DB2}"/>
+                <a16:creationId xmlns:a16="http://schemas.microsoft.com/office/drawing/2014/main" id="{22EC8359-718A-4638-8247-23B99D84614C}"/>
               </a:ext>
             </a:extLst>
           </p:cNvPr>
@@ -3248,7 +3248,7 @@
           <p:cNvPr id="3" name="">
             <a:extLst xmlns:a="http://schemas.openxmlformats.org/drawingml/2006/main">
               <a:ext uri="{FF2B5EF4-FFF2-40B4-BE49-F238E27FC236}">
-                <a16:creationId xmlns:a16="http://schemas.microsoft.com/office/drawing/2014/main" id="{3586B7DD-BC90-44D0-8236-7A64CD24F2D6}"/>
+                <a16:creationId xmlns:a16="http://schemas.microsoft.com/office/drawing/2014/main" id="{A73307A3-A078-4A11-8AF5-3B4B968DD6FA}"/>
               </a:ext>
             </a:extLst>
           </p:cNvPr>
@@ -3305,7 +3305,7 @@
           <p:cNvPr id="4" name="">
             <a:extLst xmlns:a="http://schemas.openxmlformats.org/drawingml/2006/main">
               <a:ext uri="{FF2B5EF4-FFF2-40B4-BE49-F238E27FC236}">
-                <a16:creationId xmlns:a16="http://schemas.microsoft.com/office/drawing/2014/main" id="{436F5EFC-ED0B-438E-A9D3-65AB6D8A814B}"/>
+                <a16:creationId xmlns:a16="http://schemas.microsoft.com/office/drawing/2014/main" id="{57D2AC5A-D5E1-472F-A106-8EEF5B50A8E3}"/>
               </a:ext>
             </a:extLst>
           </p:cNvPr>
@@ -3385,7 +3385,7 @@
           <p:cNvPr id="5" name="">
             <a:extLst xmlns:a="http://schemas.openxmlformats.org/drawingml/2006/main">
               <a:ext uri="{FF2B5EF4-FFF2-40B4-BE49-F238E27FC236}">
-                <a16:creationId xmlns:a16="http://schemas.microsoft.com/office/drawing/2014/main" id="{C3AA6BAA-B05B-4203-81EC-A877AB91A630}"/>
+                <a16:creationId xmlns:a16="http://schemas.microsoft.com/office/drawing/2014/main" id="{13DA4B32-9C12-429B-BA63-C00FE3582C0D}"/>
               </a:ext>
             </a:extLst>
           </p:cNvPr>
@@ -3446,7 +3446,7 @@
           <p:nvPr/>
         </p:nvPicPr>
         <p:blipFill>
-          <a:blip xmlns:r="http://schemas.openxmlformats.org/officeDocument/2006/relationships" xmlns:a="http://schemas.openxmlformats.org/drawingml/2006/main" r:embed="R081ca2cfb5704273"/>
+          <a:blip xmlns:r="http://schemas.openxmlformats.org/officeDocument/2006/relationships" xmlns:a="http://schemas.openxmlformats.org/drawingml/2006/main" r:embed="R36605b292048442d"/>
           <a:stretch xmlns:a="http://schemas.openxmlformats.org/drawingml/2006/main"/>
         </p:blipFill>
         <p:spPr>
@@ -3462,7 +3462,7 @@
     </p:spTree>
     <p:extLst>
       <p:ext uri="{BB962C8B-B14F-4D97-AF65-F5344CB8AC3E}">
-        <p14:creationId xmlns:p14="http://schemas.microsoft.com/office/powerpoint/2010/main" val="1143737236"/>
+        <p14:creationId xmlns:p14="http://schemas.microsoft.com/office/powerpoint/2010/main" val="189543240"/>
       </p:ext>
     </p:extLst>
   </p:cSld>
@@ -3493,7 +3493,7 @@
           <p:cNvPr id="9" name="">
             <a:extLst xmlns:a="http://schemas.openxmlformats.org/drawingml/2006/main">
               <a:ext uri="{FF2B5EF4-FFF2-40B4-BE49-F238E27FC236}">
-                <a16:creationId xmlns:a16="http://schemas.microsoft.com/office/drawing/2014/main" id="{19F912FA-5B9A-4584-81BC-2F92192DF5B1}"/>
+                <a16:creationId xmlns:a16="http://schemas.microsoft.com/office/drawing/2014/main" id="{9ECEC30B-9F67-456C-BFD0-57E0F15AC8B4}"/>
               </a:ext>
             </a:extLst>
           </p:cNvPr>
@@ -3550,7 +3550,7 @@
           <p:cNvPr id="2" name="">
             <a:extLst xmlns:a="http://schemas.openxmlformats.org/drawingml/2006/main">
               <a:ext uri="{FF2B5EF4-FFF2-40B4-BE49-F238E27FC236}">
-                <a16:creationId xmlns:a16="http://schemas.microsoft.com/office/drawing/2014/main" id="{4D283676-7E04-48A3-99F3-141979B68940}"/>
+                <a16:creationId xmlns:a16="http://schemas.microsoft.com/office/drawing/2014/main" id="{3BE10A16-BE39-4ECE-B662-7137E4772705}"/>
               </a:ext>
             </a:extLst>
           </p:cNvPr>
@@ -3607,7 +3607,7 @@
           <p:cNvPr id="3" name="">
             <a:extLst xmlns:a="http://schemas.openxmlformats.org/drawingml/2006/main">
               <a:ext uri="{FF2B5EF4-FFF2-40B4-BE49-F238E27FC236}">
-                <a16:creationId xmlns:a16="http://schemas.microsoft.com/office/drawing/2014/main" id="{EAE935F0-EA51-497E-97E8-16EC23E80375}"/>
+                <a16:creationId xmlns:a16="http://schemas.microsoft.com/office/drawing/2014/main" id="{35BBD62A-7B6C-4710-8B77-32B3A623D8C5}"/>
               </a:ext>
             </a:extLst>
           </p:cNvPr>
@@ -3664,7 +3664,7 @@
           <p:cNvPr id="4" name="">
             <a:extLst xmlns:a="http://schemas.openxmlformats.org/drawingml/2006/main">
               <a:ext uri="{FF2B5EF4-FFF2-40B4-BE49-F238E27FC236}">
-                <a16:creationId xmlns:a16="http://schemas.microsoft.com/office/drawing/2014/main" id="{A1E7116D-C2EA-4616-A23C-55A84BC6967A}"/>
+                <a16:creationId xmlns:a16="http://schemas.microsoft.com/office/drawing/2014/main" id="{A62BB8DA-E362-40B4-87E6-8F06FCDDE1C6}"/>
               </a:ext>
             </a:extLst>
           </p:cNvPr>
@@ -3721,7 +3721,7 @@
           <p:cNvPr id="5" name="">
             <a:extLst xmlns:a="http://schemas.openxmlformats.org/drawingml/2006/main">
               <a:ext uri="{FF2B5EF4-FFF2-40B4-BE49-F238E27FC236}">
-                <a16:creationId xmlns:a16="http://schemas.microsoft.com/office/drawing/2014/main" id="{EDEE7C1F-42A7-40E0-A5FE-453B1375A744}"/>
+                <a16:creationId xmlns:a16="http://schemas.microsoft.com/office/drawing/2014/main" id="{15215F66-8F04-4B32-9340-16D1FF488D87}"/>
               </a:ext>
             </a:extLst>
           </p:cNvPr>
@@ -3801,7 +3801,7 @@
           <p:cNvPr id="6" name="">
             <a:extLst xmlns:a="http://schemas.openxmlformats.org/drawingml/2006/main">
               <a:ext uri="{FF2B5EF4-FFF2-40B4-BE49-F238E27FC236}">
-                <a16:creationId xmlns:a16="http://schemas.microsoft.com/office/drawing/2014/main" id="{714E2814-C076-4DF1-80FA-88F95B74AF6B}"/>
+                <a16:creationId xmlns:a16="http://schemas.microsoft.com/office/drawing/2014/main" id="{47239876-FDBF-4355-BA11-72C95EA44B0C}"/>
               </a:ext>
             </a:extLst>
           </p:cNvPr>
@@ -3858,7 +3858,7 @@
           <p:cNvPr id="7" name="">
             <a:extLst xmlns:a="http://schemas.openxmlformats.org/drawingml/2006/main">
               <a:ext uri="{FF2B5EF4-FFF2-40B4-BE49-F238E27FC236}">
-                <a16:creationId xmlns:a16="http://schemas.microsoft.com/office/drawing/2014/main" id="{350246EE-FB84-4D13-BB99-99C1E5286558}"/>
+                <a16:creationId xmlns:a16="http://schemas.microsoft.com/office/drawing/2014/main" id="{95A6F85B-491B-4309-82D6-B5AA72CC1C1D}"/>
               </a:ext>
             </a:extLst>
           </p:cNvPr>
@@ -3905,7 +3905,7 @@
                 <a:ea typeface="Liberation Sans"/>
                 <a:cs typeface="Liberation Sans"/>
               </a:rPr>
-              <a:t>illustrative booked value</a:t>
+              <a:t>illustrative planned value</a:t>
             </a:r>
           </a:p>
           <a:p xmlns:a="http://schemas.openxmlformats.org/drawingml/2006/main">
@@ -3942,13 +3942,13 @@
           <p:nvPr/>
         </p:nvPicPr>
         <p:blipFill>
-          <a:blip xmlns:r="http://schemas.openxmlformats.org/officeDocument/2006/relationships" xmlns:a="http://schemas.openxmlformats.org/drawingml/2006/main" r:embed="R263edffc3d7f4402"/>
+          <a:blip xmlns:r="http://schemas.openxmlformats.org/officeDocument/2006/relationships" xmlns:a="http://schemas.openxmlformats.org/drawingml/2006/main" r:embed="R8758ed83f7654dca"/>
           <a:stretch xmlns:a="http://schemas.openxmlformats.org/drawingml/2006/main"/>
         </p:blipFill>
         <p:spPr>
           <a:xfrm xmlns:a="http://schemas.openxmlformats.org/drawingml/2006/main">
-            <a:off x="5279794" y="2009775"/>
-            <a:ext cx="5461462" cy="4171950"/>
+            <a:off x="5699907" y="2009775"/>
+            <a:ext cx="4621237" cy="4171950"/>
           </a:xfrm>
           <a:prstGeom xmlns:a="http://schemas.openxmlformats.org/drawingml/2006/main" prst="rect">
             <a:avLst/>
@@ -3958,7 +3958,7 @@
     </p:spTree>
     <p:extLst>
       <p:ext uri="{BB962C8B-B14F-4D97-AF65-F5344CB8AC3E}">
-        <p14:creationId xmlns:p14="http://schemas.microsoft.com/office/powerpoint/2010/main" val="676230895"/>
+        <p14:creationId xmlns:p14="http://schemas.microsoft.com/office/powerpoint/2010/main" val="592745189"/>
       </p:ext>
     </p:extLst>
   </p:cSld>
@@ -3989,7 +3989,7 @@
           <p:cNvPr id="6" name="">
             <a:extLst xmlns:a="http://schemas.openxmlformats.org/drawingml/2006/main">
               <a:ext uri="{FF2B5EF4-FFF2-40B4-BE49-F238E27FC236}">
-                <a16:creationId xmlns:a16="http://schemas.microsoft.com/office/drawing/2014/main" id="{3118C268-F81C-457A-B9AD-FA844BEF0110}"/>
+                <a16:creationId xmlns:a16="http://schemas.microsoft.com/office/drawing/2014/main" id="{0A370C36-1CDF-428E-80F1-AF0667ADE102}"/>
               </a:ext>
             </a:extLst>
           </p:cNvPr>
@@ -4046,7 +4046,7 @@
           <p:cNvPr id="2" name="">
             <a:extLst xmlns:a="http://schemas.openxmlformats.org/drawingml/2006/main">
               <a:ext uri="{FF2B5EF4-FFF2-40B4-BE49-F238E27FC236}">
-                <a16:creationId xmlns:a16="http://schemas.microsoft.com/office/drawing/2014/main" id="{027D333F-BDE1-45C6-B219-25820EE611B1}"/>
+                <a16:creationId xmlns:a16="http://schemas.microsoft.com/office/drawing/2014/main" id="{A929D539-8328-424E-83C8-368AE4BE3D55}"/>
               </a:ext>
             </a:extLst>
           </p:cNvPr>
@@ -4103,7 +4103,7 @@
           <p:cNvPr id="3" name="">
             <a:extLst xmlns:a="http://schemas.openxmlformats.org/drawingml/2006/main">
               <a:ext uri="{FF2B5EF4-FFF2-40B4-BE49-F238E27FC236}">
-                <a16:creationId xmlns:a16="http://schemas.microsoft.com/office/drawing/2014/main" id="{E3AAE7E9-6616-43CB-ADA8-063D322C868B}"/>
+                <a16:creationId xmlns:a16="http://schemas.microsoft.com/office/drawing/2014/main" id="{28A55DFF-C4D3-4BC2-9341-A32A08F32BD6}"/>
               </a:ext>
             </a:extLst>
           </p:cNvPr>
@@ -4432,7 +4432,7 @@
           <p:cNvPr id="5" name="">
             <a:extLst xmlns:a="http://schemas.openxmlformats.org/drawingml/2006/main">
               <a:ext uri="{FF2B5EF4-FFF2-40B4-BE49-F238E27FC236}">
-                <a16:creationId xmlns:a16="http://schemas.microsoft.com/office/drawing/2014/main" id="{CAFCCA06-7278-4974-B837-CF1649640DA6}"/>
+                <a16:creationId xmlns:a16="http://schemas.microsoft.com/office/drawing/2014/main" id="{A9B910E0-49B5-45C9-A921-9FECCCA44BA4}"/>
               </a:ext>
             </a:extLst>
           </p:cNvPr>
@@ -4487,7 +4487,7 @@
     </p:spTree>
     <p:extLst>
       <p:ext uri="{BB962C8B-B14F-4D97-AF65-F5344CB8AC3E}">
-        <p14:creationId xmlns:p14="http://schemas.microsoft.com/office/powerpoint/2010/main" val="922900918"/>
+        <p14:creationId xmlns:p14="http://schemas.microsoft.com/office/powerpoint/2010/main" val="721464581"/>
       </p:ext>
     </p:extLst>
   </p:cSld>
@@ -4518,7 +4518,7 @@
           <p:cNvPr id="9" name="">
             <a:extLst xmlns:a="http://schemas.openxmlformats.org/drawingml/2006/main">
               <a:ext uri="{FF2B5EF4-FFF2-40B4-BE49-F238E27FC236}">
-                <a16:creationId xmlns:a16="http://schemas.microsoft.com/office/drawing/2014/main" id="{0C16B13A-6396-4665-A252-7CE80A9D84E8}"/>
+                <a16:creationId xmlns:a16="http://schemas.microsoft.com/office/drawing/2014/main" id="{CE87B15B-C2E6-4950-9774-D10C53ABEF72}"/>
               </a:ext>
             </a:extLst>
           </p:cNvPr>
@@ -4575,7 +4575,7 @@
           <p:cNvPr id="2" name="">
             <a:extLst xmlns:a="http://schemas.openxmlformats.org/drawingml/2006/main">
               <a:ext uri="{FF2B5EF4-FFF2-40B4-BE49-F238E27FC236}">
-                <a16:creationId xmlns:a16="http://schemas.microsoft.com/office/drawing/2014/main" id="{F3216187-D8C3-4D13-A69A-F619C9776938}"/>
+                <a16:creationId xmlns:a16="http://schemas.microsoft.com/office/drawing/2014/main" id="{7A1DA1A7-B35C-438C-9655-989271A499A6}"/>
               </a:ext>
             </a:extLst>
           </p:cNvPr>
@@ -4632,7 +4632,7 @@
           <p:cNvPr id="3" name="">
             <a:extLst xmlns:a="http://schemas.openxmlformats.org/drawingml/2006/main">
               <a:ext uri="{FF2B5EF4-FFF2-40B4-BE49-F238E27FC236}">
-                <a16:creationId xmlns:a16="http://schemas.microsoft.com/office/drawing/2014/main" id="{2F0F0F2D-061F-4BD5-B25C-98443782D4C4}"/>
+                <a16:creationId xmlns:a16="http://schemas.microsoft.com/office/drawing/2014/main" id="{C00870B5-F35B-4349-A28C-5AD8C91293FB}"/>
               </a:ext>
             </a:extLst>
           </p:cNvPr>
@@ -4689,7 +4689,7 @@
           <p:cNvPr id="4" name="">
             <a:extLst xmlns:a="http://schemas.openxmlformats.org/drawingml/2006/main">
               <a:ext uri="{FF2B5EF4-FFF2-40B4-BE49-F238E27FC236}">
-                <a16:creationId xmlns:a16="http://schemas.microsoft.com/office/drawing/2014/main" id="{94AC60EF-0BC7-4DF2-8C29-76C75C6A5002}"/>
+                <a16:creationId xmlns:a16="http://schemas.microsoft.com/office/drawing/2014/main" id="{B67134A3-067B-462D-891E-43510EE88BC1}"/>
               </a:ext>
             </a:extLst>
           </p:cNvPr>
@@ -4746,7 +4746,7 @@
           <p:cNvPr id="5" name="">
             <a:extLst xmlns:a="http://schemas.openxmlformats.org/drawingml/2006/main">
               <a:ext uri="{FF2B5EF4-FFF2-40B4-BE49-F238E27FC236}">
-                <a16:creationId xmlns:a16="http://schemas.microsoft.com/office/drawing/2014/main" id="{A750FB55-B661-4E21-9512-C7AFD39FEE08}"/>
+                <a16:creationId xmlns:a16="http://schemas.microsoft.com/office/drawing/2014/main" id="{93D8A38C-4E3C-4FA3-9428-87E6441F9626}"/>
               </a:ext>
             </a:extLst>
           </p:cNvPr>
@@ -4793,7 +4793,7 @@
                 <a:ea typeface="Liberation Sans"/>
                 <a:cs typeface="Liberation Sans"/>
               </a:rPr>
-              <a:t>Accounts and isolated workspaces</a:t>
+              <a:t>Accounts with saved recovery keys</a:t>
             </a:r>
           </a:p>
           <a:p xmlns:a="http://schemas.openxmlformats.org/drawingml/2006/main">
@@ -4862,7 +4862,7 @@
                 <a:ea typeface="Liberation Sans"/>
                 <a:cs typeface="Liberation Sans"/>
               </a:rPr>
-              <a:t>Operator-supplied records</a:t>
+              <a:t>Operator records and capture history</a:t>
             </a:r>
           </a:p>
           <a:p xmlns:a="http://schemas.openxmlformats.org/drawingml/2006/main">
@@ -4885,7 +4885,7 @@
                 <a:ea typeface="Liberation Sans"/>
                 <a:cs typeface="Liberation Sans"/>
               </a:rPr>
-              <a:t>Version-bound review and export</a:t>
+              <a:t>Version-bound signoff and export</a:t>
             </a:r>
           </a:p>
         </p:txBody>
@@ -4895,7 +4895,7 @@
           <p:cNvPr id="6" name="">
             <a:extLst xmlns:a="http://schemas.openxmlformats.org/drawingml/2006/main">
               <a:ext uri="{FF2B5EF4-FFF2-40B4-BE49-F238E27FC236}">
-                <a16:creationId xmlns:a16="http://schemas.microsoft.com/office/drawing/2014/main" id="{28F885BD-65A5-400F-BD46-627090FE793F}"/>
+                <a16:creationId xmlns:a16="http://schemas.microsoft.com/office/drawing/2014/main" id="{C656D82F-3A24-44C2-AFB0-77425CF5E663}"/>
               </a:ext>
             </a:extLst>
           </p:cNvPr>
@@ -4952,7 +4952,7 @@
           <p:cNvPr id="7" name="">
             <a:extLst xmlns:a="http://schemas.openxmlformats.org/drawingml/2006/main">
               <a:ext uri="{FF2B5EF4-FFF2-40B4-BE49-F238E27FC236}">
-                <a16:creationId xmlns:a16="http://schemas.microsoft.com/office/drawing/2014/main" id="{D0278892-F039-4794-9A4B-8F50784C4316}"/>
+                <a16:creationId xmlns:a16="http://schemas.microsoft.com/office/drawing/2014/main" id="{6200DBF3-23AB-4022-89B2-3E831408C58F}"/>
               </a:ext>
             </a:extLst>
           </p:cNvPr>
@@ -5068,7 +5068,7 @@
                 <a:ea typeface="Liberation Sans"/>
                 <a:cs typeface="Liberation Sans"/>
               </a:rPr>
-              <a:t>Deployment-specific readiness</a:t>
+              <a:t>Operational backup and restore</a:t>
             </a:r>
           </a:p>
         </p:txBody>
@@ -5078,7 +5078,7 @@
           <p:cNvPr id="8" name="">
             <a:extLst xmlns:a="http://schemas.openxmlformats.org/drawingml/2006/main">
               <a:ext uri="{FF2B5EF4-FFF2-40B4-BE49-F238E27FC236}">
-                <a16:creationId xmlns:a16="http://schemas.microsoft.com/office/drawing/2014/main" id="{790ECD95-24DD-4BED-B689-C3004412C9FF}"/>
+                <a16:creationId xmlns:a16="http://schemas.microsoft.com/office/drawing/2014/main" id="{672E3E40-8E44-4F09-B4E9-CCE7812AD9DC}"/>
               </a:ext>
             </a:extLst>
           </p:cNvPr>
@@ -5125,7 +5125,7 @@
                 <a:ea typeface="Liberation Sans"/>
                 <a:cs typeface="Liberation Sans"/>
               </a:rPr>
-              <a:t>Simulation proves logic. A shadow pilot tests usefulness.</a:t>
+              <a:t>Covered tests demonstrate behavior. A pilot tests usefulness.</a:t>
             </a:r>
           </a:p>
         </p:txBody>
@@ -5133,7 +5133,7 @@
     </p:spTree>
     <p:extLst>
       <p:ext uri="{BB962C8B-B14F-4D97-AF65-F5344CB8AC3E}">
-        <p14:creationId xmlns:p14="http://schemas.microsoft.com/office/powerpoint/2010/main" val="1956865494"/>
+        <p14:creationId xmlns:p14="http://schemas.microsoft.com/office/powerpoint/2010/main" val="306275636"/>
       </p:ext>
     </p:extLst>
   </p:cSld>
@@ -5164,7 +5164,7 @@
           <p:cNvPr id="6" name="">
             <a:extLst xmlns:a="http://schemas.openxmlformats.org/drawingml/2006/main">
               <a:ext uri="{FF2B5EF4-FFF2-40B4-BE49-F238E27FC236}">
-                <a16:creationId xmlns:a16="http://schemas.microsoft.com/office/drawing/2014/main" id="{6DEC557A-5ED9-41E5-BE15-A13F101E65E0}"/>
+                <a16:creationId xmlns:a16="http://schemas.microsoft.com/office/drawing/2014/main" id="{45CFE385-855E-4FD2-85E7-EBF098706485}"/>
               </a:ext>
             </a:extLst>
           </p:cNvPr>
@@ -5221,7 +5221,7 @@
           <p:cNvPr id="2" name="">
             <a:extLst xmlns:a="http://schemas.openxmlformats.org/drawingml/2006/main">
               <a:ext uri="{FF2B5EF4-FFF2-40B4-BE49-F238E27FC236}">
-                <a16:creationId xmlns:a16="http://schemas.microsoft.com/office/drawing/2014/main" id="{6B0DFC5E-E1F5-408D-A847-90038E0D5381}"/>
+                <a16:creationId xmlns:a16="http://schemas.microsoft.com/office/drawing/2014/main" id="{EF1FA8DC-D2BC-4485-AA24-606A70E5CC5A}"/>
               </a:ext>
             </a:extLst>
           </p:cNvPr>
@@ -5278,7 +5278,7 @@
           <p:cNvPr id="3" name="">
             <a:extLst xmlns:a="http://schemas.openxmlformats.org/drawingml/2006/main">
               <a:ext uri="{FF2B5EF4-FFF2-40B4-BE49-F238E27FC236}">
-                <a16:creationId xmlns:a16="http://schemas.microsoft.com/office/drawing/2014/main" id="{504D8D7C-1017-4212-9C54-226259321194}"/>
+                <a16:creationId xmlns:a16="http://schemas.microsoft.com/office/drawing/2014/main" id="{3400F852-E3F6-49EC-B5E3-814F7CE1C982}"/>
               </a:ext>
             </a:extLst>
           </p:cNvPr>
@@ -5607,7 +5607,7 @@
           <p:cNvPr id="5" name="">
             <a:extLst xmlns:a="http://schemas.openxmlformats.org/drawingml/2006/main">
               <a:ext uri="{FF2B5EF4-FFF2-40B4-BE49-F238E27FC236}">
-                <a16:creationId xmlns:a16="http://schemas.microsoft.com/office/drawing/2014/main" id="{D77AB503-2AF9-4E99-ACC3-94BB0DE34314}"/>
+                <a16:creationId xmlns:a16="http://schemas.microsoft.com/office/drawing/2014/main" id="{1736F577-FB66-4CFC-AC68-00A1FD844884}"/>
               </a:ext>
             </a:extLst>
           </p:cNvPr>
@@ -5662,7 +5662,7 @@
     </p:spTree>
     <p:extLst>
       <p:ext uri="{BB962C8B-B14F-4D97-AF65-F5344CB8AC3E}">
-        <p14:creationId xmlns:p14="http://schemas.microsoft.com/office/powerpoint/2010/main" val="914845161"/>
+        <p14:creationId xmlns:p14="http://schemas.microsoft.com/office/powerpoint/2010/main" val="1093499888"/>
       </p:ext>
     </p:extLst>
   </p:cSld>
@@ -5693,7 +5693,7 @@
           <p:cNvPr id="8" name="">
             <a:extLst xmlns:a="http://schemas.openxmlformats.org/drawingml/2006/main">
               <a:ext uri="{FF2B5EF4-FFF2-40B4-BE49-F238E27FC236}">
-                <a16:creationId xmlns:a16="http://schemas.microsoft.com/office/drawing/2014/main" id="{3C9F535B-DF09-4E95-9177-C40CA2A032C3}"/>
+                <a16:creationId xmlns:a16="http://schemas.microsoft.com/office/drawing/2014/main" id="{2438B234-6E02-45F9-891B-000E021DBF49}"/>
               </a:ext>
             </a:extLst>
           </p:cNvPr>
@@ -5750,7 +5750,7 @@
           <p:cNvPr id="2" name="">
             <a:extLst xmlns:a="http://schemas.openxmlformats.org/drawingml/2006/main">
               <a:ext uri="{FF2B5EF4-FFF2-40B4-BE49-F238E27FC236}">
-                <a16:creationId xmlns:a16="http://schemas.microsoft.com/office/drawing/2014/main" id="{50A87E7A-8E8B-45B9-85E0-93FEB32E20A3}"/>
+                <a16:creationId xmlns:a16="http://schemas.microsoft.com/office/drawing/2014/main" id="{D8289194-0E39-4E48-B200-F382FFE5DAB3}"/>
               </a:ext>
             </a:extLst>
           </p:cNvPr>
@@ -5807,7 +5807,7 @@
           <p:cNvPr id="3" name="">
             <a:extLst xmlns:a="http://schemas.openxmlformats.org/drawingml/2006/main">
               <a:ext uri="{FF2B5EF4-FFF2-40B4-BE49-F238E27FC236}">
-                <a16:creationId xmlns:a16="http://schemas.microsoft.com/office/drawing/2014/main" id="{20654FBB-FDD9-4810-8685-1B53F4765CF8}"/>
+                <a16:creationId xmlns:a16="http://schemas.microsoft.com/office/drawing/2014/main" id="{AC870847-AF39-42FD-AA5F-8FEEDC55CBB2}"/>
               </a:ext>
             </a:extLst>
           </p:cNvPr>
@@ -5864,7 +5864,7 @@
           <p:cNvPr id="4" name="">
             <a:extLst xmlns:a="http://schemas.openxmlformats.org/drawingml/2006/main">
               <a:ext uri="{FF2B5EF4-FFF2-40B4-BE49-F238E27FC236}">
-                <a16:creationId xmlns:a16="http://schemas.microsoft.com/office/drawing/2014/main" id="{15C930D0-61B9-43F5-84C8-D583784A1095}"/>
+                <a16:creationId xmlns:a16="http://schemas.microsoft.com/office/drawing/2014/main" id="{8C132AC3-B677-4EF3-BA0C-1DA1D8D918C6}"/>
               </a:ext>
             </a:extLst>
           </p:cNvPr>
@@ -5921,7 +5921,7 @@
           <p:cNvPr id="5" name="">
             <a:extLst xmlns:a="http://schemas.openxmlformats.org/drawingml/2006/main">
               <a:ext uri="{FF2B5EF4-FFF2-40B4-BE49-F238E27FC236}">
-                <a16:creationId xmlns:a16="http://schemas.microsoft.com/office/drawing/2014/main" id="{662CCA19-516B-4233-BE9E-5379177CFD6A}"/>
+                <a16:creationId xmlns:a16="http://schemas.microsoft.com/office/drawing/2014/main" id="{26541CCC-EEA8-4518-BED5-88B8FDE727C0}"/>
               </a:ext>
             </a:extLst>
           </p:cNvPr>
@@ -5968,7 +5968,7 @@
                 <a:ea typeface="Liberation Sans"/>
                 <a:cs typeface="Liberation Sans"/>
               </a:rPr>
-              <a:t>Proposed future plan for 25 sites and five users</a:t>
+              <a:t>Proposed price for a coordinator workspace</a:t>
             </a:r>
           </a:p>
         </p:txBody>
@@ -6150,7 +6150,7 @@
           <p:cNvPr id="7" name="">
             <a:extLst xmlns:a="http://schemas.openxmlformats.org/drawingml/2006/main">
               <a:ext uri="{FF2B5EF4-FFF2-40B4-BE49-F238E27FC236}">
-                <a16:creationId xmlns:a16="http://schemas.microsoft.com/office/drawing/2014/main" id="{AC736D5D-F943-45B8-A6F3-C404E33FA12A}"/>
+                <a16:creationId xmlns:a16="http://schemas.microsoft.com/office/drawing/2014/main" id="{7BDFB652-A587-49A5-A4E1-7A22AC8D8F7D}"/>
               </a:ext>
             </a:extLst>
           </p:cNvPr>
@@ -6205,7 +6205,7 @@
     </p:spTree>
     <p:extLst>
       <p:ext uri="{BB962C8B-B14F-4D97-AF65-F5344CB8AC3E}">
-        <p14:creationId xmlns:p14="http://schemas.microsoft.com/office/powerpoint/2010/main" val="2003581289"/>
+        <p14:creationId xmlns:p14="http://schemas.microsoft.com/office/powerpoint/2010/main" val="1104982308"/>
       </p:ext>
     </p:extLst>
   </p:cSld>
@@ -6236,7 +6236,7 @@
           <p:cNvPr id="6" name="">
             <a:extLst xmlns:a="http://schemas.openxmlformats.org/drawingml/2006/main">
               <a:ext uri="{FF2B5EF4-FFF2-40B4-BE49-F238E27FC236}">
-                <a16:creationId xmlns:a16="http://schemas.microsoft.com/office/drawing/2014/main" id="{5FC3120E-C216-47EE-B5DC-9F6124111F96}"/>
+                <a16:creationId xmlns:a16="http://schemas.microsoft.com/office/drawing/2014/main" id="{8DF1F739-D060-44C1-B439-410CA9400F8C}"/>
               </a:ext>
             </a:extLst>
           </p:cNvPr>
@@ -6293,7 +6293,7 @@
           <p:cNvPr id="2" name="">
             <a:extLst xmlns:a="http://schemas.openxmlformats.org/drawingml/2006/main">
               <a:ext uri="{FF2B5EF4-FFF2-40B4-BE49-F238E27FC236}">
-                <a16:creationId xmlns:a16="http://schemas.microsoft.com/office/drawing/2014/main" id="{86D806F4-5788-4B1F-88F0-067C7B4260C9}"/>
+                <a16:creationId xmlns:a16="http://schemas.microsoft.com/office/drawing/2014/main" id="{242C6068-FD0A-4FD6-9CBF-7597DB33EC24}"/>
               </a:ext>
             </a:extLst>
           </p:cNvPr>
@@ -6350,7 +6350,7 @@
           <p:cNvPr id="3" name="">
             <a:extLst xmlns:a="http://schemas.openxmlformats.org/drawingml/2006/main">
               <a:ext uri="{FF2B5EF4-FFF2-40B4-BE49-F238E27FC236}">
-                <a16:creationId xmlns:a16="http://schemas.microsoft.com/office/drawing/2014/main" id="{D5C3F949-63D4-4869-AEBD-7431D96567D0}"/>
+                <a16:creationId xmlns:a16="http://schemas.microsoft.com/office/drawing/2014/main" id="{64036608-941D-40B4-A497-1BF614834068}"/>
               </a:ext>
             </a:extLst>
           </p:cNvPr>
@@ -6679,7 +6679,7 @@
           <p:cNvPr id="5" name="">
             <a:extLst xmlns:a="http://schemas.openxmlformats.org/drawingml/2006/main">
               <a:ext uri="{FF2B5EF4-FFF2-40B4-BE49-F238E27FC236}">
-                <a16:creationId xmlns:a16="http://schemas.microsoft.com/office/drawing/2014/main" id="{70E63206-47FD-4AFD-AFF0-F115A7B53C17}"/>
+                <a16:creationId xmlns:a16="http://schemas.microsoft.com/office/drawing/2014/main" id="{496E5826-348D-447A-923F-CBE0ABFF7A50}"/>
               </a:ext>
             </a:extLst>
           </p:cNvPr>
@@ -6757,7 +6757,7 @@
     </p:spTree>
     <p:extLst>
       <p:ext uri="{BB962C8B-B14F-4D97-AF65-F5344CB8AC3E}">
-        <p14:creationId xmlns:p14="http://schemas.microsoft.com/office/powerpoint/2010/main" val="1937926499"/>
+        <p14:creationId xmlns:p14="http://schemas.microsoft.com/office/powerpoint/2010/main" val="2043362033"/>
       </p:ext>
     </p:extLst>
   </p:cSld>

</xml_diff>